<commit_message>
fix: sync script + PPT v7 — 3 inconsistencies resolved
1. Layer ordering: Layer 1=Human/UI, Layer 2=Backend, Layer 3=Hermes Agent
2. Stock numbers: 5→4 everywhere (was 3→2 in script expected output)
3. Checklist: v6→v7 filename updated
</commit_message>
<xml_diff>
--- a/video-demo/TuntasUMKM-HackFest2026-v7.pptx
+++ b/video-demo/TuntasUMKM-HackFest2026-v7.pptx
@@ -792,7 +792,7 @@
           <a:lstStyle/>
           <a:p>
             <a:r>
-              <a:t>Layer 1 — MCP Exposure Control: Hermes hanya memuat 4 business capabilities. Layer 2 — Backend State-Transition Enforcement: Backend memvalidasi status sebelum menjalankan effects. Layer 3 — Human Approval: Manusia memegang keputusan final. Boundary berasal dari capability separation, bukan hanya prompt instruction.</a:t>
+              <a:t>Layer 1 — Human / UI: Manusia memegang keputusan final. Layer 2 — Backend: Backend memvalidasi status sebelum menjalankan effects. Layer 3 — Hermes Agent: Hermes hanya memuat 4 business capabilities. Boundary berasal dari capability separation, bukan hanya prompt instruction.</a:t>
             </a:r>
           </a:p>
         </p:txBody>
@@ -1212,7 +1212,7 @@
           <a:lstStyle/>
           <a:p>
             <a:r>
-              <a:t>Entry 1: agent create_draft. Entry 2: human APPROVE_ORDER. Entry 3: agent DEDUCT_STOCK. Entry 4: agent NOTIFY_CUSTOMER. Actor agent untuk DEDUCT_STOCK dan NOTIFY_CUSTOMER merepresentasikan origin workflow — backend mengeksekusi side effects atas otorisasi human approval.</a:t>
+              <a:t>Entry 1: agent create_draft. Entry 2: human APPROVE_ORDER. Entry 3: agent DEDUCT_STOCK (5→4). Entry 4: agent NOTIFY_CUSTOMER. Actor agent untuk DEDUCT_STOCK dan NOTIFY_CUSTOMER merepresentasikan origin workflow — backend mengeksekusi side effects atas otorisasi human approval.</a:t>
             </a:r>
           </a:p>
         </p:txBody>
@@ -5297,7 +5297,7 @@
               </a:defRPr>
             </a:pPr>
             <a:r>
-              <a:t>MCP Exposure + Backend Enforcement + Human Approval</a:t>
+              <a:t>Human / UI + Backend + Hermes Agent (MCP Exposure)</a:t>
             </a:r>
           </a:p>
         </p:txBody>

</xml_diff>

<commit_message>
fix: add reject_order to Scene 9, stock info to Scene 6
- Scene 9: added reject_order to Not in MCP list (now 4 tools)
- Scene 6: added stock information to dashboard detail list
- deck_spec.json: updated notes for slides 6 and 9
- PPT v7 regenerated with updated notes
</commit_message>
<xml_diff>
--- a/video-demo/TuntasUMKM-HackFest2026-v7.pptx
+++ b/video-demo/TuntasUMKM-HackFest2026-v7.pptx
@@ -582,7 +582,7 @@
           <a:lstStyle/>
           <a:p>
             <a:r>
-              <a:t>Bukan karena prompt-nya melarang agent. Tool-nya memang tidak ada di MCP registry. Honest limitation: agent memiliki execute_code dan terminal. Secara teknis bisa bypass. MCP boundary adalah model-awareness layer, bukan absolute security boundary. Security boundary yang sebenarnya ada di backend state-transition enforcement.</a:t>
+              <a:t>Available: search_catalog, check_inventory, calculate_order_total, create_order_draft. Not in MCP: approve_order, reject_order, deduct_stock, send_customer_message. Bukan karena prompt-nya melarang agent. Tool-nya memang tidak ada di MCP registry. Honest limitation: agent memiliki execute_code dan terminal. Secara teknis bisa bypass. MCP boundary adalah model-awareness layer, bukan absolute security boundary. Security boundary yang sebenarnya ada di backend state-transition enforcement.</a:t>
             </a:r>
           </a:p>
         </p:txBody>
@@ -1072,7 +1072,7 @@
           <a:lstStyle/>
           <a:p>
             <a:r>
-              <a:t>Approval adalah backend operation yang dipicu dari human approval flow. Backend enforce state-transition: hanya order berstatus pending_approval yang bisa bertransisi. Honest note: endpoint approval saat ini belum memiliki authentication. Yang di-enforce adalah state-transition validity.</a:t>
+              <a:t>Approval adalah backend operation yang dipicu dari human approval flow. Backend enforce state-transition: hanya order berstatus pending_approval yang bisa bertransisi. Honest note: endpoint approval saat ini belum memiliki authentication. Yang di-enforce adalah state-transition validity. Dashboard menampilkan: order detail, stock information, audit trail, approve/reject buttons, confirmation dialog.</a:t>
             </a:r>
           </a:p>
         </p:txBody>

</xml_diff>